<commit_message>
Redesign deck as light consulting style with embedded product screenshot
Replaces the dark dashboard-style slides with a white, steel-blue,
Office-native consulting layout: full-sentence action titles, footnoted
sources, plain process strip, and an actual screenshot of the live
calculator embedded on slide 1. Footer carries the live prototype URL
(clickable in the pptx). Content and all numbers unchanged from the
canonical model.

Co-Authored-By: Claude Fable 5 <noreply@anthropic.com>
Claude-Session: https://claude.ai/code/session_01Np6mG5uv1mTTrfsT6v544c
</commit_message>
<xml_diff>
--- a/case-study/StainlessCarbon_Round1.pptx
+++ b/case-study/StainlessCarbon_Round1.pptx
@@ -3113,6 +3113,50 @@
           </a:prstGeom>
         </p:spPr>
       </p:pic>
+      <p:sp>
+        <p:nvSpPr>
+          <p:cNvPr id="3" name="Rectangle 2">
+            <a:hlinkClick r:id="rId3"/>
+          </p:cNvPr>
+          <p:cNvSpPr/>
+          <p:nvPr/>
+        </p:nvSpPr>
+        <p:spPr>
+          <a:xfrm>
+            <a:off x="182880" y="6419088"/>
+            <a:ext cx="11795760" cy="411480"/>
+          </a:xfrm>
+          <a:prstGeom prst="rect">
+            <a:avLst/>
+          </a:prstGeom>
+          <a:noFill/>
+          <a:ln>
+            <a:noFill/>
+          </a:ln>
+          <a:effectLst/>
+        </p:spPr>
+        <p:style>
+          <a:lnRef idx="1">
+            <a:schemeClr val="accent1"/>
+          </a:lnRef>
+          <a:fillRef idx="3">
+            <a:schemeClr val="accent1"/>
+          </a:fillRef>
+          <a:effectRef idx="2">
+            <a:schemeClr val="accent1"/>
+          </a:effectRef>
+          <a:fontRef idx="minor">
+            <a:schemeClr val="lt1"/>
+          </a:fontRef>
+        </p:style>
+        <p:txBody>
+          <a:bodyPr rtlCol="0" anchor="ctr"/>
+          <a:lstStyle/>
+          <a:p>
+            <a:pPr algn="ctr"/>
+          </a:p>
+        </p:txBody>
+      </p:sp>
     </p:spTree>
   </p:cSld>
   <p:clrMapOvr>
@@ -3155,6 +3199,50 @@
           </a:prstGeom>
         </p:spPr>
       </p:pic>
+      <p:sp>
+        <p:nvSpPr>
+          <p:cNvPr id="3" name="Rectangle 2">
+            <a:hlinkClick r:id="rId3"/>
+          </p:cNvPr>
+          <p:cNvSpPr/>
+          <p:nvPr/>
+        </p:nvSpPr>
+        <p:spPr>
+          <a:xfrm>
+            <a:off x="182880" y="6419088"/>
+            <a:ext cx="11795760" cy="411480"/>
+          </a:xfrm>
+          <a:prstGeom prst="rect">
+            <a:avLst/>
+          </a:prstGeom>
+          <a:noFill/>
+          <a:ln>
+            <a:noFill/>
+          </a:ln>
+          <a:effectLst/>
+        </p:spPr>
+        <p:style>
+          <a:lnRef idx="1">
+            <a:schemeClr val="accent1"/>
+          </a:lnRef>
+          <a:fillRef idx="3">
+            <a:schemeClr val="accent1"/>
+          </a:fillRef>
+          <a:effectRef idx="2">
+            <a:schemeClr val="accent1"/>
+          </a:effectRef>
+          <a:fontRef idx="minor">
+            <a:schemeClr val="lt1"/>
+          </a:fontRef>
+        </p:style>
+        <p:txBody>
+          <a:bodyPr rtlCol="0" anchor="ctr"/>
+          <a:lstStyle/>
+          <a:p>
+            <a:pPr algn="ctr"/>
+          </a:p>
+        </p:txBody>
+      </p:sp>
     </p:spTree>
   </p:cSld>
   <p:clrMapOvr>

</xml_diff>

<commit_message>
Add research appendix (PDF + source) and link it from the deck
- appendix.pdf: 12-section compiled research appendix (canonical model,
  factors, ISSF methodology, JSL disclosures, CBAM, CPR/ESPR/DPP, EU
  exposure, competitor teardown, scrap ceiling, advanced levers,
  assumptions, source register) served via GitHub Pages
- Deck footers now carry both links (live tool + appendix), clickable in
  the pptx; Primetals optimizer/CBAM cells and roadmap spacing finalized

Co-Authored-By: Claude Fable 5 <noreply@anthropic.com>
Claude-Session: https://claude.ai/code/session_01Np6mG5uv1mTTrfsT6v544c
</commit_message>
<xml_diff>
--- a/case-study/StainlessCarbon_Round1.pptx
+++ b/case-study/StainlessCarbon_Round1.pptx
@@ -3124,7 +3124,51 @@
         <p:spPr>
           <a:xfrm>
             <a:off x="182880" y="6419088"/>
-            <a:ext cx="11795760" cy="411480"/>
+            <a:ext cx="7680960" cy="411480"/>
+          </a:xfrm>
+          <a:prstGeom prst="rect">
+            <a:avLst/>
+          </a:prstGeom>
+          <a:noFill/>
+          <a:ln>
+            <a:noFill/>
+          </a:ln>
+          <a:effectLst/>
+        </p:spPr>
+        <p:style>
+          <a:lnRef idx="1">
+            <a:schemeClr val="accent1"/>
+          </a:lnRef>
+          <a:fillRef idx="3">
+            <a:schemeClr val="accent1"/>
+          </a:fillRef>
+          <a:effectRef idx="2">
+            <a:schemeClr val="accent1"/>
+          </a:effectRef>
+          <a:fontRef idx="minor">
+            <a:schemeClr val="lt1"/>
+          </a:fontRef>
+        </p:style>
+        <p:txBody>
+          <a:bodyPr rtlCol="0" anchor="ctr"/>
+          <a:lstStyle/>
+          <a:p>
+            <a:pPr algn="ctr"/>
+          </a:p>
+        </p:txBody>
+      </p:sp>
+      <p:sp>
+        <p:nvSpPr>
+          <p:cNvPr id="4" name="Rectangle 3">
+            <a:hlinkClick r:id="rId4"/>
+          </p:cNvPr>
+          <p:cNvSpPr/>
+          <p:nvPr/>
+        </p:nvSpPr>
+        <p:spPr>
+          <a:xfrm>
+            <a:off x="7955279" y="6419088"/>
+            <a:ext cx="4023360" cy="411480"/>
           </a:xfrm>
           <a:prstGeom prst="rect">
             <a:avLst/>
@@ -3210,7 +3254,51 @@
         <p:spPr>
           <a:xfrm>
             <a:off x="182880" y="6419088"/>
-            <a:ext cx="11795760" cy="411480"/>
+            <a:ext cx="7680960" cy="411480"/>
+          </a:xfrm>
+          <a:prstGeom prst="rect">
+            <a:avLst/>
+          </a:prstGeom>
+          <a:noFill/>
+          <a:ln>
+            <a:noFill/>
+          </a:ln>
+          <a:effectLst/>
+        </p:spPr>
+        <p:style>
+          <a:lnRef idx="1">
+            <a:schemeClr val="accent1"/>
+          </a:lnRef>
+          <a:fillRef idx="3">
+            <a:schemeClr val="accent1"/>
+          </a:fillRef>
+          <a:effectRef idx="2">
+            <a:schemeClr val="accent1"/>
+          </a:effectRef>
+          <a:fontRef idx="minor">
+            <a:schemeClr val="lt1"/>
+          </a:fontRef>
+        </p:style>
+        <p:txBody>
+          <a:bodyPr rtlCol="0" anchor="ctr"/>
+          <a:lstStyle/>
+          <a:p>
+            <a:pPr algn="ctr"/>
+          </a:p>
+        </p:txBody>
+      </p:sp>
+      <p:sp>
+        <p:nvSpPr>
+          <p:cNvPr id="4" name="Rectangle 3">
+            <a:hlinkClick r:id="rId4"/>
+          </p:cNvPr>
+          <p:cNvSpPr/>
+          <p:nvPr/>
+        </p:nvSpPr>
+        <p:spPr>
+          <a:xfrm>
+            <a:off x="7955279" y="6419088"/>
+            <a:ext cx="4023360" cy="411480"/>
           </a:xfrm>
           <a:prstGeom prst="rect">
             <a:avLst/>

</xml_diff>